<commit_message>
ajusta la portada de la presentacion
</commit_message>
<xml_diff>
--- a/Presentacion/TrainerOS_TFI_Presentacion.pptx
+++ b/Presentacion/TrainerOS_TFI_Presentacion.pptx
@@ -5,19 +5,19 @@
     <p:sldMasterId id="2147483648" r:id="rId1"/>
   </p:sldMasterIdLst>
   <p:sldIdLst>
-    <p:sldId id="256" r:id="rId7"/>
-    <p:sldId id="257" r:id="rId8"/>
-    <p:sldId id="258" r:id="rId9"/>
-    <p:sldId id="259" r:id="rId10"/>
-    <p:sldId id="260" r:id="rId11"/>
-    <p:sldId id="261" r:id="rId12"/>
-    <p:sldId id="262" r:id="rId13"/>
-    <p:sldId id="263" r:id="rId14"/>
-    <p:sldId id="264" r:id="rId15"/>
-    <p:sldId id="265" r:id="rId16"/>
-    <p:sldId id="266" r:id="rId17"/>
+    <p:sldId id="256" r:id="rId2"/>
+    <p:sldId id="257" r:id="rId3"/>
+    <p:sldId id="258" r:id="rId4"/>
+    <p:sldId id="259" r:id="rId5"/>
+    <p:sldId id="260" r:id="rId6"/>
+    <p:sldId id="261" r:id="rId7"/>
+    <p:sldId id="262" r:id="rId8"/>
+    <p:sldId id="263" r:id="rId9"/>
+    <p:sldId id="264" r:id="rId10"/>
+    <p:sldId id="265" r:id="rId11"/>
+    <p:sldId id="266" r:id="rId12"/>
   </p:sldIdLst>
-  <p:sldSz cx="12191695" cy="6858000" type="screen4x3"/>
+  <p:sldSz cx="12192000" cy="6858000"/>
   <p:notesSz cx="6858000" cy="9144000"/>
   <p:defaultTextStyle>
     <a:defPPr>
@@ -114,6 +114,22 @@
       </a:defRPr>
     </a:lvl9pPr>
   </p:defaultTextStyle>
+  <p:extLst>
+    <p:ext uri="{EFAFB233-063F-42B5-8137-9DF3F51BA10A}">
+      <p15:sldGuideLst xmlns:p15="http://schemas.microsoft.com/office/powerpoint/2012/main">
+        <p15:guide id="1" orient="horz" pos="2160">
+          <p15:clr>
+            <a:srgbClr val="A4A3A4"/>
+          </p15:clr>
+        </p15:guide>
+        <p15:guide id="2" pos="2880">
+          <p15:clr>
+            <a:srgbClr val="A4A3A4"/>
+          </p15:clr>
+        </p15:guide>
+      </p15:sldGuideLst>
+    </p:ext>
+  </p:extLst>
 </p:presentation>
 </file>
 
@@ -155,10 +171,9 @@
           <a:lstStyle/>
           <a:p>
             <a:r>
-              <a:rPr lang="en-US" smtClean="0"/>
+              <a:rPr lang="en-US"/>
               <a:t>Click to edit Master title style</a:t>
             </a:r>
-            <a:endParaRPr lang="en-US"/>
           </a:p>
         </p:txBody>
       </p:sp>
@@ -274,10 +289,9 @@
           </a:lstStyle>
           <a:p>
             <a:r>
-              <a:rPr lang="en-US" smtClean="0"/>
+              <a:rPr lang="en-US"/>
               <a:t>Click to edit Master subtitle style</a:t>
             </a:r>
-            <a:endParaRPr lang="en-US"/>
           </a:p>
         </p:txBody>
       </p:sp>
@@ -298,7 +312,7 @@
           <a:p>
             <a:fld id="{5BCAD085-E8A6-8845-BD4E-CB4CCA059FC4}" type="datetimeFigureOut">
               <a:rPr lang="en-US" smtClean="0"/>
-              <a:t>1/27/13</a:t>
+              <a:t>6/16/2026</a:t>
             </a:fld>
             <a:endParaRPr lang="en-US"/>
           </a:p>
@@ -340,7 +354,7 @@
           <a:p>
             <a:fld id="{C1FF6DA9-008F-8B48-92A6-B652298478BF}" type="slidenum">
               <a:rPr lang="en-US" smtClean="0"/>
-              <a:t>‹#›</a:t>
+              <a:t>‹Nº›</a:t>
             </a:fld>
             <a:endParaRPr lang="en-US"/>
           </a:p>
@@ -392,10 +406,9 @@
           <a:lstStyle/>
           <a:p>
             <a:r>
-              <a:rPr lang="en-US" smtClean="0"/>
+              <a:rPr lang="en-US"/>
               <a:t>Click to edit Master title style</a:t>
             </a:r>
-            <a:endParaRPr lang="en-US"/>
           </a:p>
         </p:txBody>
       </p:sp>
@@ -416,38 +429,37 @@
           <a:p>
             <a:pPr lvl="0"/>
             <a:r>
-              <a:rPr lang="en-US" smtClean="0"/>
+              <a:rPr lang="en-US"/>
               <a:t>Click to edit Master text styles</a:t>
             </a:r>
           </a:p>
           <a:p>
             <a:pPr lvl="1"/>
             <a:r>
-              <a:rPr lang="en-US" smtClean="0"/>
+              <a:rPr lang="en-US"/>
               <a:t>Second level</a:t>
             </a:r>
           </a:p>
           <a:p>
             <a:pPr lvl="2"/>
             <a:r>
-              <a:rPr lang="en-US" smtClean="0"/>
+              <a:rPr lang="en-US"/>
               <a:t>Third level</a:t>
             </a:r>
           </a:p>
           <a:p>
             <a:pPr lvl="3"/>
             <a:r>
-              <a:rPr lang="en-US" smtClean="0"/>
+              <a:rPr lang="en-US"/>
               <a:t>Fourth level</a:t>
             </a:r>
           </a:p>
           <a:p>
             <a:pPr lvl="4"/>
             <a:r>
-              <a:rPr lang="en-US" smtClean="0"/>
+              <a:rPr lang="en-US"/>
               <a:t>Fifth level</a:t>
             </a:r>
-            <a:endParaRPr lang="en-US"/>
           </a:p>
         </p:txBody>
       </p:sp>
@@ -468,7 +480,7 @@
           <a:p>
             <a:fld id="{5BCAD085-E8A6-8845-BD4E-CB4CCA059FC4}" type="datetimeFigureOut">
               <a:rPr lang="en-US" smtClean="0"/>
-              <a:t>1/27/13</a:t>
+              <a:t>6/16/2026</a:t>
             </a:fld>
             <a:endParaRPr lang="en-US"/>
           </a:p>
@@ -510,7 +522,7 @@
           <a:p>
             <a:fld id="{C1FF6DA9-008F-8B48-92A6-B652298478BF}" type="slidenum">
               <a:rPr lang="en-US" smtClean="0"/>
-              <a:t>‹#›</a:t>
+              <a:t>‹Nº›</a:t>
             </a:fld>
             <a:endParaRPr lang="en-US"/>
           </a:p>
@@ -567,10 +579,9 @@
           <a:lstStyle/>
           <a:p>
             <a:r>
-              <a:rPr lang="en-US" smtClean="0"/>
+              <a:rPr lang="en-US"/>
               <a:t>Click to edit Master title style</a:t>
             </a:r>
-            <a:endParaRPr lang="en-US"/>
           </a:p>
         </p:txBody>
       </p:sp>
@@ -596,38 +607,37 @@
           <a:p>
             <a:pPr lvl="0"/>
             <a:r>
-              <a:rPr lang="en-US" smtClean="0"/>
+              <a:rPr lang="en-US"/>
               <a:t>Click to edit Master text styles</a:t>
             </a:r>
           </a:p>
           <a:p>
             <a:pPr lvl="1"/>
             <a:r>
-              <a:rPr lang="en-US" smtClean="0"/>
+              <a:rPr lang="en-US"/>
               <a:t>Second level</a:t>
             </a:r>
           </a:p>
           <a:p>
             <a:pPr lvl="2"/>
             <a:r>
-              <a:rPr lang="en-US" smtClean="0"/>
+              <a:rPr lang="en-US"/>
               <a:t>Third level</a:t>
             </a:r>
           </a:p>
           <a:p>
             <a:pPr lvl="3"/>
             <a:r>
-              <a:rPr lang="en-US" smtClean="0"/>
+              <a:rPr lang="en-US"/>
               <a:t>Fourth level</a:t>
             </a:r>
           </a:p>
           <a:p>
             <a:pPr lvl="4"/>
             <a:r>
-              <a:rPr lang="en-US" smtClean="0"/>
+              <a:rPr lang="en-US"/>
               <a:t>Fifth level</a:t>
             </a:r>
-            <a:endParaRPr lang="en-US"/>
           </a:p>
         </p:txBody>
       </p:sp>
@@ -648,7 +658,7 @@
           <a:p>
             <a:fld id="{5BCAD085-E8A6-8845-BD4E-CB4CCA059FC4}" type="datetimeFigureOut">
               <a:rPr lang="en-US" smtClean="0"/>
-              <a:t>1/27/13</a:t>
+              <a:t>6/16/2026</a:t>
             </a:fld>
             <a:endParaRPr lang="en-US"/>
           </a:p>
@@ -690,7 +700,7 @@
           <a:p>
             <a:fld id="{C1FF6DA9-008F-8B48-92A6-B652298478BF}" type="slidenum">
               <a:rPr lang="en-US" smtClean="0"/>
-              <a:t>‹#›</a:t>
+              <a:t>‹Nº›</a:t>
             </a:fld>
             <a:endParaRPr lang="en-US"/>
           </a:p>
@@ -742,10 +752,9 @@
           <a:lstStyle/>
           <a:p>
             <a:r>
-              <a:rPr lang="en-US" smtClean="0"/>
+              <a:rPr lang="en-US"/>
               <a:t>Click to edit Master title style</a:t>
             </a:r>
-            <a:endParaRPr lang="en-US"/>
           </a:p>
         </p:txBody>
       </p:sp>
@@ -766,38 +775,37 @@
           <a:p>
             <a:pPr lvl="0"/>
             <a:r>
-              <a:rPr lang="en-US" smtClean="0"/>
+              <a:rPr lang="en-US"/>
               <a:t>Click to edit Master text styles</a:t>
             </a:r>
           </a:p>
           <a:p>
             <a:pPr lvl="1"/>
             <a:r>
-              <a:rPr lang="en-US" smtClean="0"/>
+              <a:rPr lang="en-US"/>
               <a:t>Second level</a:t>
             </a:r>
           </a:p>
           <a:p>
             <a:pPr lvl="2"/>
             <a:r>
-              <a:rPr lang="en-US" smtClean="0"/>
+              <a:rPr lang="en-US"/>
               <a:t>Third level</a:t>
             </a:r>
           </a:p>
           <a:p>
             <a:pPr lvl="3"/>
             <a:r>
-              <a:rPr lang="en-US" smtClean="0"/>
+              <a:rPr lang="en-US"/>
               <a:t>Fourth level</a:t>
             </a:r>
           </a:p>
           <a:p>
             <a:pPr lvl="4"/>
             <a:r>
-              <a:rPr lang="en-US" smtClean="0"/>
+              <a:rPr lang="en-US"/>
               <a:t>Fifth level</a:t>
             </a:r>
-            <a:endParaRPr lang="en-US"/>
           </a:p>
         </p:txBody>
       </p:sp>
@@ -818,7 +826,7 @@
           <a:p>
             <a:fld id="{5BCAD085-E8A6-8845-BD4E-CB4CCA059FC4}" type="datetimeFigureOut">
               <a:rPr lang="en-US" smtClean="0"/>
-              <a:t>1/27/13</a:t>
+              <a:t>6/16/2026</a:t>
             </a:fld>
             <a:endParaRPr lang="en-US"/>
           </a:p>
@@ -860,7 +868,7 @@
           <a:p>
             <a:fld id="{C1FF6DA9-008F-8B48-92A6-B652298478BF}" type="slidenum">
               <a:rPr lang="en-US" smtClean="0"/>
-              <a:t>‹#›</a:t>
+              <a:t>‹Nº›</a:t>
             </a:fld>
             <a:endParaRPr lang="en-US"/>
           </a:p>
@@ -921,10 +929,9 @@
           </a:lstStyle>
           <a:p>
             <a:r>
-              <a:rPr lang="en-US" smtClean="0"/>
+              <a:rPr lang="en-US"/>
               <a:t>Click to edit Master title style</a:t>
             </a:r>
-            <a:endParaRPr lang="en-US"/>
           </a:p>
         </p:txBody>
       </p:sp>
@@ -1041,7 +1048,7 @@
           <a:p>
             <a:pPr lvl="0"/>
             <a:r>
-              <a:rPr lang="en-US" smtClean="0"/>
+              <a:rPr lang="en-US"/>
               <a:t>Click to edit Master text styles</a:t>
             </a:r>
           </a:p>
@@ -1064,7 +1071,7 @@
           <a:p>
             <a:fld id="{5BCAD085-E8A6-8845-BD4E-CB4CCA059FC4}" type="datetimeFigureOut">
               <a:rPr lang="en-US" smtClean="0"/>
-              <a:t>1/27/13</a:t>
+              <a:t>6/16/2026</a:t>
             </a:fld>
             <a:endParaRPr lang="en-US"/>
           </a:p>
@@ -1106,7 +1113,7 @@
           <a:p>
             <a:fld id="{C1FF6DA9-008F-8B48-92A6-B652298478BF}" type="slidenum">
               <a:rPr lang="en-US" smtClean="0"/>
-              <a:t>‹#›</a:t>
+              <a:t>‹Nº›</a:t>
             </a:fld>
             <a:endParaRPr lang="en-US"/>
           </a:p>
@@ -1158,10 +1165,9 @@
           <a:lstStyle/>
           <a:p>
             <a:r>
-              <a:rPr lang="en-US" smtClean="0"/>
+              <a:rPr lang="en-US"/>
               <a:t>Click to edit Master title style</a:t>
             </a:r>
-            <a:endParaRPr lang="en-US"/>
           </a:p>
         </p:txBody>
       </p:sp>
@@ -1215,38 +1221,37 @@
           <a:p>
             <a:pPr lvl="0"/>
             <a:r>
-              <a:rPr lang="en-US" smtClean="0"/>
+              <a:rPr lang="en-US"/>
               <a:t>Click to edit Master text styles</a:t>
             </a:r>
           </a:p>
           <a:p>
             <a:pPr lvl="1"/>
             <a:r>
-              <a:rPr lang="en-US" smtClean="0"/>
+              <a:rPr lang="en-US"/>
               <a:t>Second level</a:t>
             </a:r>
           </a:p>
           <a:p>
             <a:pPr lvl="2"/>
             <a:r>
-              <a:rPr lang="en-US" smtClean="0"/>
+              <a:rPr lang="en-US"/>
               <a:t>Third level</a:t>
             </a:r>
           </a:p>
           <a:p>
             <a:pPr lvl="3"/>
             <a:r>
-              <a:rPr lang="en-US" smtClean="0"/>
+              <a:rPr lang="en-US"/>
               <a:t>Fourth level</a:t>
             </a:r>
           </a:p>
           <a:p>
             <a:pPr lvl="4"/>
             <a:r>
-              <a:rPr lang="en-US" smtClean="0"/>
+              <a:rPr lang="en-US"/>
               <a:t>Fifth level</a:t>
             </a:r>
-            <a:endParaRPr lang="en-US"/>
           </a:p>
         </p:txBody>
       </p:sp>
@@ -1300,38 +1305,37 @@
           <a:p>
             <a:pPr lvl="0"/>
             <a:r>
-              <a:rPr lang="en-US" smtClean="0"/>
+              <a:rPr lang="en-US"/>
               <a:t>Click to edit Master text styles</a:t>
             </a:r>
           </a:p>
           <a:p>
             <a:pPr lvl="1"/>
             <a:r>
-              <a:rPr lang="en-US" smtClean="0"/>
+              <a:rPr lang="en-US"/>
               <a:t>Second level</a:t>
             </a:r>
           </a:p>
           <a:p>
             <a:pPr lvl="2"/>
             <a:r>
-              <a:rPr lang="en-US" smtClean="0"/>
+              <a:rPr lang="en-US"/>
               <a:t>Third level</a:t>
             </a:r>
           </a:p>
           <a:p>
             <a:pPr lvl="3"/>
             <a:r>
-              <a:rPr lang="en-US" smtClean="0"/>
+              <a:rPr lang="en-US"/>
               <a:t>Fourth level</a:t>
             </a:r>
           </a:p>
           <a:p>
             <a:pPr lvl="4"/>
             <a:r>
-              <a:rPr lang="en-US" smtClean="0"/>
+              <a:rPr lang="en-US"/>
               <a:t>Fifth level</a:t>
             </a:r>
-            <a:endParaRPr lang="en-US"/>
           </a:p>
         </p:txBody>
       </p:sp>
@@ -1352,7 +1356,7 @@
           <a:p>
             <a:fld id="{5BCAD085-E8A6-8845-BD4E-CB4CCA059FC4}" type="datetimeFigureOut">
               <a:rPr lang="en-US" smtClean="0"/>
-              <a:t>1/27/13</a:t>
+              <a:t>6/16/2026</a:t>
             </a:fld>
             <a:endParaRPr lang="en-US"/>
           </a:p>
@@ -1394,7 +1398,7 @@
           <a:p>
             <a:fld id="{C1FF6DA9-008F-8B48-92A6-B652298478BF}" type="slidenum">
               <a:rPr lang="en-US" smtClean="0"/>
-              <a:t>‹#›</a:t>
+              <a:t>‹Nº›</a:t>
             </a:fld>
             <a:endParaRPr lang="en-US"/>
           </a:p>
@@ -1450,10 +1454,9 @@
           </a:lstStyle>
           <a:p>
             <a:r>
-              <a:rPr lang="en-US" smtClean="0"/>
+              <a:rPr lang="en-US"/>
               <a:t>Click to edit Master title style</a:t>
             </a:r>
-            <a:endParaRPr lang="en-US"/>
           </a:p>
         </p:txBody>
       </p:sp>
@@ -1516,7 +1519,7 @@
           <a:p>
             <a:pPr lvl="0"/>
             <a:r>
-              <a:rPr lang="en-US" smtClean="0"/>
+              <a:rPr lang="en-US"/>
               <a:t>Click to edit Master text styles</a:t>
             </a:r>
           </a:p>
@@ -1572,38 +1575,37 @@
           <a:p>
             <a:pPr lvl="0"/>
             <a:r>
-              <a:rPr lang="en-US" smtClean="0"/>
+              <a:rPr lang="en-US"/>
               <a:t>Click to edit Master text styles</a:t>
             </a:r>
           </a:p>
           <a:p>
             <a:pPr lvl="1"/>
             <a:r>
-              <a:rPr lang="en-US" smtClean="0"/>
+              <a:rPr lang="en-US"/>
               <a:t>Second level</a:t>
             </a:r>
           </a:p>
           <a:p>
             <a:pPr lvl="2"/>
             <a:r>
-              <a:rPr lang="en-US" smtClean="0"/>
+              <a:rPr lang="en-US"/>
               <a:t>Third level</a:t>
             </a:r>
           </a:p>
           <a:p>
             <a:pPr lvl="3"/>
             <a:r>
-              <a:rPr lang="en-US" smtClean="0"/>
+              <a:rPr lang="en-US"/>
               <a:t>Fourth level</a:t>
             </a:r>
           </a:p>
           <a:p>
             <a:pPr lvl="4"/>
             <a:r>
-              <a:rPr lang="en-US" smtClean="0"/>
+              <a:rPr lang="en-US"/>
               <a:t>Fifth level</a:t>
             </a:r>
-            <a:endParaRPr lang="en-US"/>
           </a:p>
         </p:txBody>
       </p:sp>
@@ -1666,7 +1668,7 @@
           <a:p>
             <a:pPr lvl="0"/>
             <a:r>
-              <a:rPr lang="en-US" smtClean="0"/>
+              <a:rPr lang="en-US"/>
               <a:t>Click to edit Master text styles</a:t>
             </a:r>
           </a:p>
@@ -1722,38 +1724,37 @@
           <a:p>
             <a:pPr lvl="0"/>
             <a:r>
-              <a:rPr lang="en-US" smtClean="0"/>
+              <a:rPr lang="en-US"/>
               <a:t>Click to edit Master text styles</a:t>
             </a:r>
           </a:p>
           <a:p>
             <a:pPr lvl="1"/>
             <a:r>
-              <a:rPr lang="en-US" smtClean="0"/>
+              <a:rPr lang="en-US"/>
               <a:t>Second level</a:t>
             </a:r>
           </a:p>
           <a:p>
             <a:pPr lvl="2"/>
             <a:r>
-              <a:rPr lang="en-US" smtClean="0"/>
+              <a:rPr lang="en-US"/>
               <a:t>Third level</a:t>
             </a:r>
           </a:p>
           <a:p>
             <a:pPr lvl="3"/>
             <a:r>
-              <a:rPr lang="en-US" smtClean="0"/>
+              <a:rPr lang="en-US"/>
               <a:t>Fourth level</a:t>
             </a:r>
           </a:p>
           <a:p>
             <a:pPr lvl="4"/>
             <a:r>
-              <a:rPr lang="en-US" smtClean="0"/>
+              <a:rPr lang="en-US"/>
               <a:t>Fifth level</a:t>
             </a:r>
-            <a:endParaRPr lang="en-US"/>
           </a:p>
         </p:txBody>
       </p:sp>
@@ -1774,7 +1775,7 @@
           <a:p>
             <a:fld id="{5BCAD085-E8A6-8845-BD4E-CB4CCA059FC4}" type="datetimeFigureOut">
               <a:rPr lang="en-US" smtClean="0"/>
-              <a:t>1/27/13</a:t>
+              <a:t>6/16/2026</a:t>
             </a:fld>
             <a:endParaRPr lang="en-US"/>
           </a:p>
@@ -1816,7 +1817,7 @@
           <a:p>
             <a:fld id="{C1FF6DA9-008F-8B48-92A6-B652298478BF}" type="slidenum">
               <a:rPr lang="en-US" smtClean="0"/>
-              <a:t>‹#›</a:t>
+              <a:t>‹Nº›</a:t>
             </a:fld>
             <a:endParaRPr lang="en-US"/>
           </a:p>
@@ -1868,10 +1869,9 @@
           <a:lstStyle/>
           <a:p>
             <a:r>
-              <a:rPr lang="en-US" smtClean="0"/>
+              <a:rPr lang="en-US"/>
               <a:t>Click to edit Master title style</a:t>
             </a:r>
-            <a:endParaRPr lang="en-US"/>
           </a:p>
         </p:txBody>
       </p:sp>
@@ -1892,7 +1892,7 @@
           <a:p>
             <a:fld id="{5BCAD085-E8A6-8845-BD4E-CB4CCA059FC4}" type="datetimeFigureOut">
               <a:rPr lang="en-US" smtClean="0"/>
-              <a:t>1/27/13</a:t>
+              <a:t>6/16/2026</a:t>
             </a:fld>
             <a:endParaRPr lang="en-US"/>
           </a:p>
@@ -1934,7 +1934,7 @@
           <a:p>
             <a:fld id="{C1FF6DA9-008F-8B48-92A6-B652298478BF}" type="slidenum">
               <a:rPr lang="en-US" smtClean="0"/>
-              <a:t>‹#›</a:t>
+              <a:t>‹Nº›</a:t>
             </a:fld>
             <a:endParaRPr lang="en-US"/>
           </a:p>
@@ -1987,7 +1987,7 @@
           <a:p>
             <a:fld id="{5BCAD085-E8A6-8845-BD4E-CB4CCA059FC4}" type="datetimeFigureOut">
               <a:rPr lang="en-US" smtClean="0"/>
-              <a:t>1/27/13</a:t>
+              <a:t>6/16/2026</a:t>
             </a:fld>
             <a:endParaRPr lang="en-US"/>
           </a:p>
@@ -2029,7 +2029,7 @@
           <a:p>
             <a:fld id="{C1FF6DA9-008F-8B48-92A6-B652298478BF}" type="slidenum">
               <a:rPr lang="en-US" smtClean="0"/>
-              <a:t>‹#›</a:t>
+              <a:t>‹Nº›</a:t>
             </a:fld>
             <a:endParaRPr lang="en-US"/>
           </a:p>
@@ -2090,10 +2090,9 @@
           </a:lstStyle>
           <a:p>
             <a:r>
-              <a:rPr lang="en-US" smtClean="0"/>
+              <a:rPr lang="en-US"/>
               <a:t>Click to edit Master title style</a:t>
             </a:r>
-            <a:endParaRPr lang="en-US"/>
           </a:p>
         </p:txBody>
       </p:sp>
@@ -2147,38 +2146,37 @@
           <a:p>
             <a:pPr lvl="0"/>
             <a:r>
-              <a:rPr lang="en-US" smtClean="0"/>
+              <a:rPr lang="en-US"/>
               <a:t>Click to edit Master text styles</a:t>
             </a:r>
           </a:p>
           <a:p>
             <a:pPr lvl="1"/>
             <a:r>
-              <a:rPr lang="en-US" smtClean="0"/>
+              <a:rPr lang="en-US"/>
               <a:t>Second level</a:t>
             </a:r>
           </a:p>
           <a:p>
             <a:pPr lvl="2"/>
             <a:r>
-              <a:rPr lang="en-US" smtClean="0"/>
+              <a:rPr lang="en-US"/>
               <a:t>Third level</a:t>
             </a:r>
           </a:p>
           <a:p>
             <a:pPr lvl="3"/>
             <a:r>
-              <a:rPr lang="en-US" smtClean="0"/>
+              <a:rPr lang="en-US"/>
               <a:t>Fourth level</a:t>
             </a:r>
           </a:p>
           <a:p>
             <a:pPr lvl="4"/>
             <a:r>
-              <a:rPr lang="en-US" smtClean="0"/>
+              <a:rPr lang="en-US"/>
               <a:t>Fifth level</a:t>
             </a:r>
-            <a:endParaRPr lang="en-US"/>
           </a:p>
         </p:txBody>
       </p:sp>
@@ -2241,7 +2239,7 @@
           <a:p>
             <a:pPr lvl="0"/>
             <a:r>
-              <a:rPr lang="en-US" smtClean="0"/>
+              <a:rPr lang="en-US"/>
               <a:t>Click to edit Master text styles</a:t>
             </a:r>
           </a:p>
@@ -2264,7 +2262,7 @@
           <a:p>
             <a:fld id="{5BCAD085-E8A6-8845-BD4E-CB4CCA059FC4}" type="datetimeFigureOut">
               <a:rPr lang="en-US" smtClean="0"/>
-              <a:t>1/27/13</a:t>
+              <a:t>6/16/2026</a:t>
             </a:fld>
             <a:endParaRPr lang="en-US"/>
           </a:p>
@@ -2306,7 +2304,7 @@
           <a:p>
             <a:fld id="{C1FF6DA9-008F-8B48-92A6-B652298478BF}" type="slidenum">
               <a:rPr lang="en-US" smtClean="0"/>
-              <a:t>‹#›</a:t>
+              <a:t>‹Nº›</a:t>
             </a:fld>
             <a:endParaRPr lang="en-US"/>
           </a:p>
@@ -2367,10 +2365,9 @@
           </a:lstStyle>
           <a:p>
             <a:r>
-              <a:rPr lang="en-US" smtClean="0"/>
+              <a:rPr lang="en-US"/>
               <a:t>Click to edit Master title style</a:t>
             </a:r>
-            <a:endParaRPr lang="en-US"/>
           </a:p>
         </p:txBody>
       </p:sp>
@@ -2494,7 +2491,7 @@
           <a:p>
             <a:pPr lvl="0"/>
             <a:r>
-              <a:rPr lang="en-US" smtClean="0"/>
+              <a:rPr lang="en-US"/>
               <a:t>Click to edit Master text styles</a:t>
             </a:r>
           </a:p>
@@ -2517,7 +2514,7 @@
           <a:p>
             <a:fld id="{5BCAD085-E8A6-8845-BD4E-CB4CCA059FC4}" type="datetimeFigureOut">
               <a:rPr lang="en-US" smtClean="0"/>
-              <a:t>1/27/13</a:t>
+              <a:t>6/16/2026</a:t>
             </a:fld>
             <a:endParaRPr lang="en-US"/>
           </a:p>
@@ -2559,7 +2556,7 @@
           <a:p>
             <a:fld id="{C1FF6DA9-008F-8B48-92A6-B652298478BF}" type="slidenum">
               <a:rPr lang="en-US" smtClean="0"/>
-              <a:t>‹#›</a:t>
+              <a:t>‹Nº›</a:t>
             </a:fld>
             <a:endParaRPr lang="en-US"/>
           </a:p>
@@ -2626,10 +2623,9 @@
           <a:lstStyle/>
           <a:p>
             <a:r>
-              <a:rPr lang="en-US" smtClean="0"/>
+              <a:rPr lang="en-US"/>
               <a:t>Click to edit Master title style</a:t>
             </a:r>
-            <a:endParaRPr lang="en-US"/>
           </a:p>
         </p:txBody>
       </p:sp>
@@ -2660,38 +2656,37 @@
           <a:p>
             <a:pPr lvl="0"/>
             <a:r>
-              <a:rPr lang="en-US" smtClean="0"/>
+              <a:rPr lang="en-US"/>
               <a:t>Click to edit Master text styles</a:t>
             </a:r>
           </a:p>
           <a:p>
             <a:pPr lvl="1"/>
             <a:r>
-              <a:rPr lang="en-US" smtClean="0"/>
+              <a:rPr lang="en-US"/>
               <a:t>Second level</a:t>
             </a:r>
           </a:p>
           <a:p>
             <a:pPr lvl="2"/>
             <a:r>
-              <a:rPr lang="en-US" smtClean="0"/>
+              <a:rPr lang="en-US"/>
               <a:t>Third level</a:t>
             </a:r>
           </a:p>
           <a:p>
             <a:pPr lvl="3"/>
             <a:r>
-              <a:rPr lang="en-US" smtClean="0"/>
+              <a:rPr lang="en-US"/>
               <a:t>Fourth level</a:t>
             </a:r>
           </a:p>
           <a:p>
             <a:pPr lvl="4"/>
             <a:r>
-              <a:rPr lang="en-US" smtClean="0"/>
+              <a:rPr lang="en-US"/>
               <a:t>Fifth level</a:t>
             </a:r>
-            <a:endParaRPr lang="en-US"/>
           </a:p>
         </p:txBody>
       </p:sp>
@@ -2730,7 +2725,7 @@
           <a:p>
             <a:fld id="{5BCAD085-E8A6-8845-BD4E-CB4CCA059FC4}" type="datetimeFigureOut">
               <a:rPr lang="en-US" smtClean="0"/>
-              <a:t>1/27/13</a:t>
+              <a:t>6/16/2026</a:t>
             </a:fld>
             <a:endParaRPr lang="en-US"/>
           </a:p>
@@ -2808,7 +2803,7 @@
           <a:p>
             <a:fld id="{C1FF6DA9-008F-8B48-92A6-B652298478BF}" type="slidenum">
               <a:rPr lang="en-US" smtClean="0"/>
-              <a:t>‹#›</a:t>
+              <a:t>‹Nº›</a:t>
             </a:fld>
             <a:endParaRPr lang="en-US"/>
           </a:p>
@@ -3089,7 +3084,7 @@
 </file>
 
 <file path=ppt/slides/slide1.xml><?xml version="1.0" encoding="utf-8"?>
-<p:sld xmlns:a="http://schemas.openxmlformats.org/drawingml/2006/main" xmlns:p="http://schemas.openxmlformats.org/presentationml/2006/main" xmlns:r="http://schemas.openxmlformats.org/officeDocument/2006/relationships">
+<p:sld xmlns:a="http://schemas.openxmlformats.org/drawingml/2006/main" xmlns:r="http://schemas.openxmlformats.org/officeDocument/2006/relationships" xmlns:p="http://schemas.openxmlformats.org/presentationml/2006/main">
   <p:cSld>
     <p:spTree>
       <p:nvGrpSpPr>
@@ -3097,7 +3092,14 @@
         <p:cNvGrpSpPr/>
         <p:nvPr/>
       </p:nvGrpSpPr>
-      <p:grpSpPr/>
+      <p:grpSpPr>
+        <a:xfrm>
+          <a:off x="0" y="0"/>
+          <a:ext cx="0" cy="0"/>
+          <a:chOff x="0" y="0"/>
+          <a:chExt cx="0" cy="0"/>
+        </a:xfrm>
+      </p:grpSpPr>
       <p:sp>
         <p:nvSpPr>
           <p:cNvPr id="2" name="Rectangle 1"/>
@@ -3139,6 +3141,7 @@
           <a:lstStyle/>
           <a:p>
             <a:pPr algn="ctr"/>
+            <a:endParaRPr/>
           </a:p>
         </p:txBody>
       </p:sp>
@@ -3159,7 +3162,7 @@
           <a:noFill/>
         </p:spPr>
         <p:txBody>
-          <a:bodyPr wrap="square" anchor="t" lIns="0" rIns="0" tIns="0" bIns="0">
+          <a:bodyPr wrap="square" lIns="0" tIns="0" rIns="0" bIns="0" anchor="t">
             <a:spAutoFit/>
           </a:bodyPr>
           <a:lstStyle/>
@@ -3179,14 +3182,14 @@
       </p:sp>
       <p:sp>
         <p:nvSpPr>
-          <p:cNvPr id="4" name="TextBox 3"/>
+          <p:cNvPr id="5" name="TextBox 4"/>
           <p:cNvSpPr txBox="1"/>
           <p:nvPr/>
         </p:nvSpPr>
         <p:spPr>
           <a:xfrm>
-            <a:off x="731520" y="3218688"/>
-            <a:ext cx="10725912" cy="502920"/>
+            <a:off x="731520" y="3063240"/>
+            <a:ext cx="10725912" cy="411480"/>
           </a:xfrm>
           <a:prstGeom prst="rect">
             <a:avLst/>
@@ -3194,56 +3197,72 @@
           <a:noFill/>
         </p:spPr>
         <p:txBody>
-          <a:bodyPr wrap="square" anchor="t" lIns="0" rIns="0" tIns="0" bIns="0">
+          <a:bodyPr wrap="square" lIns="0" tIns="0" rIns="0" bIns="0" anchor="t">
             <a:spAutoFit/>
           </a:bodyPr>
           <a:lstStyle/>
           <a:p>
             <a:pPr algn="ctr"/>
             <a:r>
-              <a:rPr sz="2200" b="1">
-                <a:solidFill>
-                  <a:srgbClr val="E8741E"/>
-                </a:solidFill>
-                <a:latin typeface="Segoe UI"/>
-              </a:rPr>
-              <a:t>“Del Código a la Arquitectura: El Criterio del Desarrollador”</a:t>
-            </a:r>
-          </a:p>
-        </p:txBody>
-      </p:sp>
-      <p:sp>
-        <p:nvSpPr>
-          <p:cNvPr id="5" name="TextBox 4"/>
-          <p:cNvSpPr txBox="1"/>
-          <p:nvPr/>
-        </p:nvSpPr>
-        <p:spPr>
-          <a:xfrm>
-            <a:off x="731520" y="3822191"/>
-            <a:ext cx="10725912" cy="411480"/>
-          </a:xfrm>
-          <a:prstGeom prst="rect">
-            <a:avLst/>
-          </a:prstGeom>
-          <a:noFill/>
-        </p:spPr>
-        <p:txBody>
-          <a:bodyPr wrap="square" anchor="t" lIns="0" rIns="0" tIns="0" bIns="0">
-            <a:spAutoFit/>
-          </a:bodyPr>
-          <a:lstStyle/>
-          <a:p>
-            <a:pPr algn="ctr"/>
-            <a:r>
-              <a:rPr sz="1500" b="0">
+              <a:rPr sz="1500" b="0" dirty="0">
                 <a:solidFill>
                   <a:srgbClr val="D6E0EA"/>
                 </a:solidFill>
                 <a:latin typeface="Segoe UI"/>
               </a:rPr>
-              <a:t>Plataforma SaaS de gestión para entrenadores personales</a:t>
-            </a:r>
+              <a:t>Plataforma SaaS de </a:t>
+            </a:r>
+            <a:r>
+              <a:rPr sz="1500" b="0" dirty="0" err="1">
+                <a:solidFill>
+                  <a:srgbClr val="D6E0EA"/>
+                </a:solidFill>
+                <a:latin typeface="Segoe UI"/>
+              </a:rPr>
+              <a:t>gestión</a:t>
+            </a:r>
+            <a:r>
+              <a:rPr sz="1500" b="0" dirty="0">
+                <a:solidFill>
+                  <a:srgbClr val="D6E0EA"/>
+                </a:solidFill>
+                <a:latin typeface="Segoe UI"/>
+              </a:rPr>
+              <a:t> para </a:t>
+            </a:r>
+            <a:r>
+              <a:rPr sz="1500" b="0" dirty="0" err="1">
+                <a:solidFill>
+                  <a:srgbClr val="D6E0EA"/>
+                </a:solidFill>
+                <a:latin typeface="Segoe UI"/>
+              </a:rPr>
+              <a:t>entrenadores</a:t>
+            </a:r>
+            <a:r>
+              <a:rPr sz="1500" b="0" dirty="0">
+                <a:solidFill>
+                  <a:srgbClr val="D6E0EA"/>
+                </a:solidFill>
+                <a:latin typeface="Segoe UI"/>
+              </a:rPr>
+              <a:t> </a:t>
+            </a:r>
+            <a:r>
+              <a:rPr sz="1500" b="0" dirty="0" err="1">
+                <a:solidFill>
+                  <a:srgbClr val="D6E0EA"/>
+                </a:solidFill>
+                <a:latin typeface="Segoe UI"/>
+              </a:rPr>
+              <a:t>personales</a:t>
+            </a:r>
+            <a:endParaRPr sz="1500" b="0" dirty="0">
+              <a:solidFill>
+                <a:srgbClr val="D6E0EA"/>
+              </a:solidFill>
+              <a:latin typeface="Segoe UI"/>
+            </a:endParaRPr>
           </a:p>
         </p:txBody>
       </p:sp>
@@ -3288,6 +3307,7 @@
           <a:lstStyle/>
           <a:p>
             <a:pPr algn="ctr"/>
+            <a:endParaRPr/>
           </a:p>
         </p:txBody>
       </p:sp>
@@ -3308,7 +3328,7 @@
           <a:noFill/>
         </p:spPr>
         <p:txBody>
-          <a:bodyPr wrap="square" anchor="t" lIns="0" rIns="0" tIns="0" bIns="0">
+          <a:bodyPr wrap="square" lIns="0" tIns="0" rIns="0" bIns="0" anchor="t">
             <a:spAutoFit/>
           </a:bodyPr>
           <a:lstStyle/>
@@ -3343,7 +3363,7 @@
           <a:noFill/>
         </p:spPr>
         <p:txBody>
-          <a:bodyPr wrap="square" anchor="t" lIns="0" rIns="0" tIns="0" bIns="0">
+          <a:bodyPr wrap="square" lIns="0" tIns="0" rIns="0" bIns="0" anchor="t">
             <a:spAutoFit/>
           </a:bodyPr>
           <a:lstStyle/>
@@ -3386,7 +3406,7 @@
 </file>
 
 <file path=ppt/slides/slide10.xml><?xml version="1.0" encoding="utf-8"?>
-<p:sld xmlns:a="http://schemas.openxmlformats.org/drawingml/2006/main" xmlns:p="http://schemas.openxmlformats.org/presentationml/2006/main" xmlns:r="http://schemas.openxmlformats.org/officeDocument/2006/relationships">
+<p:sld xmlns:a="http://schemas.openxmlformats.org/drawingml/2006/main" xmlns:r="http://schemas.openxmlformats.org/officeDocument/2006/relationships" xmlns:p="http://schemas.openxmlformats.org/presentationml/2006/main">
   <p:cSld>
     <p:spTree>
       <p:nvGrpSpPr>
@@ -3394,7 +3414,14 @@
         <p:cNvGrpSpPr/>
         <p:nvPr/>
       </p:nvGrpSpPr>
-      <p:grpSpPr/>
+      <p:grpSpPr>
+        <a:xfrm>
+          <a:off x="0" y="0"/>
+          <a:ext cx="0" cy="0"/>
+          <a:chOff x="0" y="0"/>
+          <a:chExt cx="0" cy="0"/>
+        </a:xfrm>
+      </p:grpSpPr>
       <p:pic>
         <p:nvPicPr>
           <p:cNvPr id="2" name="Picture 1" descr="fase5_integracion_ia.png"/>
@@ -3460,6 +3487,7 @@
           <a:lstStyle/>
           <a:p>
             <a:pPr algn="ctr"/>
+            <a:endParaRPr/>
           </a:p>
         </p:txBody>
       </p:sp>
@@ -3480,7 +3508,7 @@
           <a:noFill/>
         </p:spPr>
         <p:txBody>
-          <a:bodyPr wrap="square" anchor="t" lIns="0" rIns="0" tIns="0" bIns="0">
+          <a:bodyPr wrap="square" lIns="0" tIns="0" rIns="0" bIns="0" anchor="t">
             <a:spAutoFit/>
           </a:bodyPr>
           <a:lstStyle/>
@@ -3507,7 +3535,7 @@
 </file>
 
 <file path=ppt/slides/slide11.xml><?xml version="1.0" encoding="utf-8"?>
-<p:sld xmlns:a="http://schemas.openxmlformats.org/drawingml/2006/main" xmlns:p="http://schemas.openxmlformats.org/presentationml/2006/main" xmlns:r="http://schemas.openxmlformats.org/officeDocument/2006/relationships">
+<p:sld xmlns:a="http://schemas.openxmlformats.org/drawingml/2006/main" xmlns:r="http://schemas.openxmlformats.org/officeDocument/2006/relationships" xmlns:p="http://schemas.openxmlformats.org/presentationml/2006/main">
   <p:cSld>
     <p:spTree>
       <p:nvGrpSpPr>
@@ -3515,7 +3543,14 @@
         <p:cNvGrpSpPr/>
         <p:nvPr/>
       </p:nvGrpSpPr>
-      <p:grpSpPr/>
+      <p:grpSpPr>
+        <a:xfrm>
+          <a:off x="0" y="0"/>
+          <a:ext cx="0" cy="0"/>
+          <a:chOff x="0" y="0"/>
+          <a:chExt cx="0" cy="0"/>
+        </a:xfrm>
+      </p:grpSpPr>
       <p:sp>
         <p:nvSpPr>
           <p:cNvPr id="2" name="TextBox 1"/>
@@ -3533,7 +3568,7 @@
           <a:noFill/>
         </p:spPr>
         <p:txBody>
-          <a:bodyPr wrap="square" anchor="t" lIns="0" rIns="0" tIns="0" bIns="0">
+          <a:bodyPr wrap="square" lIns="0" tIns="0" rIns="0" bIns="0" anchor="t">
             <a:spAutoFit/>
           </a:bodyPr>
           <a:lstStyle/>
@@ -3568,7 +3603,7 @@
           <a:noFill/>
         </p:spPr>
         <p:txBody>
-          <a:bodyPr wrap="square" anchor="t" lIns="0" rIns="0" tIns="0" bIns="0">
+          <a:bodyPr wrap="square" lIns="0" tIns="0" rIns="0" bIns="0" anchor="t">
             <a:spAutoFit/>
           </a:bodyPr>
           <a:lstStyle/>
@@ -3627,6 +3662,7 @@
           <a:lstStyle/>
           <a:p>
             <a:pPr algn="ctr"/>
+            <a:endParaRPr/>
           </a:p>
         </p:txBody>
       </p:sp>
@@ -3647,7 +3683,7 @@
           <a:noFill/>
         </p:spPr>
         <p:txBody>
-          <a:bodyPr wrap="square" anchor="ctr" lIns="0" rIns="0" tIns="0" bIns="0">
+          <a:bodyPr wrap="square" lIns="0" tIns="0" rIns="0" bIns="0" anchor="ctr">
             <a:spAutoFit/>
           </a:bodyPr>
           <a:lstStyle/>
@@ -3706,6 +3742,7 @@
           <a:lstStyle/>
           <a:p>
             <a:pPr algn="ctr"/>
+            <a:endParaRPr/>
           </a:p>
         </p:txBody>
       </p:sp>
@@ -3726,7 +3763,7 @@
           <a:noFill/>
         </p:spPr>
         <p:txBody>
-          <a:bodyPr wrap="square" anchor="ctr" lIns="0" rIns="0" tIns="0" bIns="0">
+          <a:bodyPr wrap="square" lIns="0" tIns="0" rIns="0" bIns="0" anchor="ctr">
             <a:spAutoFit/>
           </a:bodyPr>
           <a:lstStyle/>
@@ -3808,6 +3845,7 @@
           <a:lstStyle/>
           <a:p>
             <a:pPr algn="ctr"/>
+            <a:endParaRPr/>
           </a:p>
         </p:txBody>
       </p:sp>
@@ -3828,7 +3866,7 @@
           <a:noFill/>
         </p:spPr>
         <p:txBody>
-          <a:bodyPr wrap="square" anchor="ctr" lIns="0" rIns="0" tIns="0" bIns="0">
+          <a:bodyPr wrap="square" lIns="0" tIns="0" rIns="0" bIns="0" anchor="ctr">
             <a:spAutoFit/>
           </a:bodyPr>
           <a:lstStyle/>
@@ -3887,6 +3925,7 @@
           <a:lstStyle/>
           <a:p>
             <a:pPr algn="ctr"/>
+            <a:endParaRPr/>
           </a:p>
         </p:txBody>
       </p:sp>
@@ -3907,7 +3946,7 @@
           <a:noFill/>
         </p:spPr>
         <p:txBody>
-          <a:bodyPr wrap="square" anchor="ctr" lIns="0" rIns="0" tIns="0" bIns="0">
+          <a:bodyPr wrap="square" lIns="0" tIns="0" rIns="0" bIns="0" anchor="ctr">
             <a:spAutoFit/>
           </a:bodyPr>
           <a:lstStyle/>
@@ -3989,6 +4028,7 @@
           <a:lstStyle/>
           <a:p>
             <a:pPr algn="ctr"/>
+            <a:endParaRPr/>
           </a:p>
         </p:txBody>
       </p:sp>
@@ -4009,7 +4049,7 @@
           <a:noFill/>
         </p:spPr>
         <p:txBody>
-          <a:bodyPr wrap="square" anchor="ctr" lIns="0" rIns="0" tIns="0" bIns="0">
+          <a:bodyPr wrap="square" lIns="0" tIns="0" rIns="0" bIns="0" anchor="ctr">
             <a:spAutoFit/>
           </a:bodyPr>
           <a:lstStyle/>
@@ -4068,6 +4108,7 @@
           <a:lstStyle/>
           <a:p>
             <a:pPr algn="ctr"/>
+            <a:endParaRPr/>
           </a:p>
         </p:txBody>
       </p:sp>
@@ -4088,7 +4129,7 @@
           <a:noFill/>
         </p:spPr>
         <p:txBody>
-          <a:bodyPr wrap="square" anchor="ctr" lIns="0" rIns="0" tIns="0" bIns="0">
+          <a:bodyPr wrap="square" lIns="0" tIns="0" rIns="0" bIns="0" anchor="ctr">
             <a:spAutoFit/>
           </a:bodyPr>
           <a:lstStyle/>
@@ -4170,6 +4211,7 @@
           <a:lstStyle/>
           <a:p>
             <a:pPr algn="ctr"/>
+            <a:endParaRPr/>
           </a:p>
         </p:txBody>
       </p:sp>
@@ -4190,7 +4232,7 @@
           <a:noFill/>
         </p:spPr>
         <p:txBody>
-          <a:bodyPr wrap="square" anchor="ctr" lIns="0" rIns="0" tIns="0" bIns="0">
+          <a:bodyPr wrap="square" lIns="0" tIns="0" rIns="0" bIns="0" anchor="ctr">
             <a:spAutoFit/>
           </a:bodyPr>
           <a:lstStyle/>
@@ -4249,6 +4291,7 @@
           <a:lstStyle/>
           <a:p>
             <a:pPr algn="ctr"/>
+            <a:endParaRPr/>
           </a:p>
         </p:txBody>
       </p:sp>
@@ -4269,7 +4312,7 @@
           <a:noFill/>
         </p:spPr>
         <p:txBody>
-          <a:bodyPr wrap="square" anchor="ctr" lIns="0" rIns="0" tIns="0" bIns="0">
+          <a:bodyPr wrap="square" lIns="0" tIns="0" rIns="0" bIns="0" anchor="ctr">
             <a:spAutoFit/>
           </a:bodyPr>
           <a:lstStyle/>
@@ -4351,6 +4394,7 @@
           <a:lstStyle/>
           <a:p>
             <a:pPr algn="ctr"/>
+            <a:endParaRPr/>
           </a:p>
         </p:txBody>
       </p:sp>
@@ -4371,7 +4415,7 @@
           <a:noFill/>
         </p:spPr>
         <p:txBody>
-          <a:bodyPr wrap="square" anchor="ctr" lIns="0" rIns="0" tIns="0" bIns="0">
+          <a:bodyPr wrap="square" lIns="0" tIns="0" rIns="0" bIns="0" anchor="ctr">
             <a:spAutoFit/>
           </a:bodyPr>
           <a:lstStyle/>
@@ -4430,6 +4474,7 @@
           <a:lstStyle/>
           <a:p>
             <a:pPr algn="ctr"/>
+            <a:endParaRPr/>
           </a:p>
         </p:txBody>
       </p:sp>
@@ -4450,7 +4495,7 @@
           <a:noFill/>
         </p:spPr>
         <p:txBody>
-          <a:bodyPr wrap="square" anchor="ctr" lIns="0" rIns="0" tIns="0" bIns="0">
+          <a:bodyPr wrap="square" lIns="0" tIns="0" rIns="0" bIns="0" anchor="ctr">
             <a:spAutoFit/>
           </a:bodyPr>
           <a:lstStyle/>
@@ -4532,6 +4577,7 @@
           <a:lstStyle/>
           <a:p>
             <a:pPr algn="ctr"/>
+            <a:endParaRPr/>
           </a:p>
         </p:txBody>
       </p:sp>
@@ -4552,7 +4598,7 @@
           <a:noFill/>
         </p:spPr>
         <p:txBody>
-          <a:bodyPr wrap="square" anchor="ctr" lIns="0" rIns="0" tIns="0" bIns="0">
+          <a:bodyPr wrap="square" lIns="0" tIns="0" rIns="0" bIns="0" anchor="ctr">
             <a:spAutoFit/>
           </a:bodyPr>
           <a:lstStyle/>
@@ -4620,6 +4666,7 @@
           <a:lstStyle/>
           <a:p>
             <a:pPr algn="ctr"/>
+            <a:endParaRPr/>
           </a:p>
         </p:txBody>
       </p:sp>
@@ -4640,7 +4687,7 @@
           <a:noFill/>
         </p:spPr>
         <p:txBody>
-          <a:bodyPr wrap="square" anchor="t" lIns="0" rIns="0" tIns="0" bIns="0">
+          <a:bodyPr wrap="square" lIns="0" tIns="0" rIns="0" bIns="0" anchor="t">
             <a:spAutoFit/>
           </a:bodyPr>
           <a:lstStyle/>
@@ -4667,7 +4714,7 @@
 </file>
 
 <file path=ppt/slides/slide2.xml><?xml version="1.0" encoding="utf-8"?>
-<p:sld xmlns:a="http://schemas.openxmlformats.org/drawingml/2006/main" xmlns:p="http://schemas.openxmlformats.org/presentationml/2006/main" xmlns:r="http://schemas.openxmlformats.org/officeDocument/2006/relationships">
+<p:sld xmlns:a="http://schemas.openxmlformats.org/drawingml/2006/main" xmlns:r="http://schemas.openxmlformats.org/officeDocument/2006/relationships" xmlns:p="http://schemas.openxmlformats.org/presentationml/2006/main">
   <p:cSld>
     <p:spTree>
       <p:nvGrpSpPr>
@@ -4675,7 +4722,14 @@
         <p:cNvGrpSpPr/>
         <p:nvPr/>
       </p:nvGrpSpPr>
-      <p:grpSpPr/>
+      <p:grpSpPr>
+        <a:xfrm>
+          <a:off x="0" y="0"/>
+          <a:ext cx="0" cy="0"/>
+          <a:chOff x="0" y="0"/>
+          <a:chExt cx="0" cy="0"/>
+        </a:xfrm>
+      </p:grpSpPr>
       <p:sp>
         <p:nvSpPr>
           <p:cNvPr id="2" name="TextBox 1"/>
@@ -4693,7 +4747,7 @@
           <a:noFill/>
         </p:spPr>
         <p:txBody>
-          <a:bodyPr wrap="square" anchor="t" lIns="0" rIns="0" tIns="0" bIns="0">
+          <a:bodyPr wrap="square" lIns="0" tIns="0" rIns="0" bIns="0" anchor="t">
             <a:spAutoFit/>
           </a:bodyPr>
           <a:lstStyle/>
@@ -4728,7 +4782,7 @@
           <a:noFill/>
         </p:spPr>
         <p:txBody>
-          <a:bodyPr wrap="square" anchor="t" lIns="0" rIns="0" tIns="0" bIns="0">
+          <a:bodyPr wrap="square" lIns="0" tIns="0" rIns="0" bIns="0" anchor="t">
             <a:spAutoFit/>
           </a:bodyPr>
           <a:lstStyle/>
@@ -4787,6 +4841,7 @@
           <a:lstStyle/>
           <a:p>
             <a:pPr algn="ctr"/>
+            <a:endParaRPr/>
           </a:p>
         </p:txBody>
       </p:sp>
@@ -4807,7 +4862,7 @@
           <a:noFill/>
         </p:spPr>
         <p:txBody>
-          <a:bodyPr wrap="square" anchor="t" lIns="0" rIns="0" tIns="0" bIns="0">
+          <a:bodyPr wrap="square" lIns="0" tIns="0" rIns="0" bIns="0" anchor="t">
             <a:spAutoFit/>
           </a:bodyPr>
           <a:lstStyle/>
@@ -4923,6 +4978,7 @@
           <a:lstStyle/>
           <a:p>
             <a:pPr algn="ctr"/>
+            <a:endParaRPr/>
           </a:p>
         </p:txBody>
       </p:sp>
@@ -4943,7 +4999,7 @@
           <a:noFill/>
         </p:spPr>
         <p:txBody>
-          <a:bodyPr wrap="square" anchor="t" lIns="0" rIns="0" tIns="0" bIns="0">
+          <a:bodyPr wrap="square" lIns="0" tIns="0" rIns="0" bIns="0" anchor="t">
             <a:spAutoFit/>
           </a:bodyPr>
           <a:lstStyle/>
@@ -5026,7 +5082,7 @@
           <a:noFill/>
         </p:spPr>
         <p:txBody>
-          <a:bodyPr wrap="square" anchor="t" lIns="0" rIns="0" tIns="0" bIns="0">
+          <a:bodyPr wrap="square" lIns="0" tIns="0" rIns="0" bIns="0" anchor="t">
             <a:spAutoFit/>
           </a:bodyPr>
           <a:lstStyle/>
@@ -5085,6 +5141,7 @@
           <a:lstStyle/>
           <a:p>
             <a:pPr algn="ctr"/>
+            <a:endParaRPr/>
           </a:p>
         </p:txBody>
       </p:sp>
@@ -5129,6 +5186,7 @@
           <a:lstStyle/>
           <a:p>
             <a:pPr algn="ctr"/>
+            <a:endParaRPr/>
           </a:p>
         </p:txBody>
       </p:sp>
@@ -5149,7 +5207,7 @@
           <a:noFill/>
         </p:spPr>
         <p:txBody>
-          <a:bodyPr wrap="square" anchor="t" lIns="0" rIns="0" tIns="0" bIns="0">
+          <a:bodyPr wrap="square" lIns="0" tIns="0" rIns="0" bIns="0" anchor="t">
             <a:spAutoFit/>
           </a:bodyPr>
           <a:lstStyle/>
@@ -5231,6 +5289,7 @@
           <a:lstStyle/>
           <a:p>
             <a:pPr algn="ctr"/>
+            <a:endParaRPr/>
           </a:p>
         </p:txBody>
       </p:sp>
@@ -5275,6 +5334,7 @@
           <a:lstStyle/>
           <a:p>
             <a:pPr algn="ctr"/>
+            <a:endParaRPr/>
           </a:p>
         </p:txBody>
       </p:sp>
@@ -5295,7 +5355,7 @@
           <a:noFill/>
         </p:spPr>
         <p:txBody>
-          <a:bodyPr wrap="square" anchor="t" lIns="0" rIns="0" tIns="0" bIns="0">
+          <a:bodyPr wrap="square" lIns="0" tIns="0" rIns="0" bIns="0" anchor="t">
             <a:spAutoFit/>
           </a:bodyPr>
           <a:lstStyle/>
@@ -5377,6 +5437,7 @@
           <a:lstStyle/>
           <a:p>
             <a:pPr algn="ctr"/>
+            <a:endParaRPr/>
           </a:p>
         </p:txBody>
       </p:sp>
@@ -5421,6 +5482,7 @@
           <a:lstStyle/>
           <a:p>
             <a:pPr algn="ctr"/>
+            <a:endParaRPr/>
           </a:p>
         </p:txBody>
       </p:sp>
@@ -5441,7 +5503,7 @@
           <a:noFill/>
         </p:spPr>
         <p:txBody>
-          <a:bodyPr wrap="square" anchor="t" lIns="0" rIns="0" tIns="0" bIns="0">
+          <a:bodyPr wrap="square" lIns="0" tIns="0" rIns="0" bIns="0" anchor="t">
             <a:spAutoFit/>
           </a:bodyPr>
           <a:lstStyle/>
@@ -5523,6 +5585,7 @@
           <a:lstStyle/>
           <a:p>
             <a:pPr algn="ctr"/>
+            <a:endParaRPr/>
           </a:p>
         </p:txBody>
       </p:sp>
@@ -5567,6 +5630,7 @@
           <a:lstStyle/>
           <a:p>
             <a:pPr algn="ctr"/>
+            <a:endParaRPr/>
           </a:p>
         </p:txBody>
       </p:sp>
@@ -5587,7 +5651,7 @@
           <a:noFill/>
         </p:spPr>
         <p:txBody>
-          <a:bodyPr wrap="square" anchor="t" lIns="0" rIns="0" tIns="0" bIns="0">
+          <a:bodyPr wrap="square" lIns="0" tIns="0" rIns="0" bIns="0" anchor="t">
             <a:spAutoFit/>
           </a:bodyPr>
           <a:lstStyle/>
@@ -5669,6 +5733,7 @@
           <a:lstStyle/>
           <a:p>
             <a:pPr algn="ctr"/>
+            <a:endParaRPr/>
           </a:p>
         </p:txBody>
       </p:sp>
@@ -5689,7 +5754,7 @@
           <a:noFill/>
         </p:spPr>
         <p:txBody>
-          <a:bodyPr wrap="square" anchor="t" lIns="0" rIns="0" tIns="0" bIns="0">
+          <a:bodyPr wrap="square" lIns="0" tIns="0" rIns="0" bIns="0" anchor="t">
             <a:spAutoFit/>
           </a:bodyPr>
           <a:lstStyle/>
@@ -5716,7 +5781,7 @@
 </file>
 
 <file path=ppt/slides/slide3.xml><?xml version="1.0" encoding="utf-8"?>
-<p:sld xmlns:a="http://schemas.openxmlformats.org/drawingml/2006/main" xmlns:p="http://schemas.openxmlformats.org/presentationml/2006/main" xmlns:r="http://schemas.openxmlformats.org/officeDocument/2006/relationships">
+<p:sld xmlns:a="http://schemas.openxmlformats.org/drawingml/2006/main" xmlns:r="http://schemas.openxmlformats.org/officeDocument/2006/relationships" xmlns:p="http://schemas.openxmlformats.org/presentationml/2006/main">
   <p:cSld>
     <p:spTree>
       <p:nvGrpSpPr>
@@ -5724,7 +5789,14 @@
         <p:cNvGrpSpPr/>
         <p:nvPr/>
       </p:nvGrpSpPr>
-      <p:grpSpPr/>
+      <p:grpSpPr>
+        <a:xfrm>
+          <a:off x="0" y="0"/>
+          <a:ext cx="0" cy="0"/>
+          <a:chOff x="0" y="0"/>
+          <a:chExt cx="0" cy="0"/>
+        </a:xfrm>
+      </p:grpSpPr>
       <p:pic>
         <p:nvPicPr>
           <p:cNvPr id="2" name="Picture 1" descr="fase1_monolito_3capas.png"/>
@@ -5790,6 +5862,7 @@
           <a:lstStyle/>
           <a:p>
             <a:pPr algn="ctr"/>
+            <a:endParaRPr/>
           </a:p>
         </p:txBody>
       </p:sp>
@@ -5810,7 +5883,7 @@
           <a:noFill/>
         </p:spPr>
         <p:txBody>
-          <a:bodyPr wrap="square" anchor="t" lIns="0" rIns="0" tIns="0" bIns="0">
+          <a:bodyPr wrap="square" lIns="0" tIns="0" rIns="0" bIns="0" anchor="t">
             <a:spAutoFit/>
           </a:bodyPr>
           <a:lstStyle/>
@@ -5837,7 +5910,7 @@
 </file>
 
 <file path=ppt/slides/slide4.xml><?xml version="1.0" encoding="utf-8"?>
-<p:sld xmlns:a="http://schemas.openxmlformats.org/drawingml/2006/main" xmlns:p="http://schemas.openxmlformats.org/presentationml/2006/main" xmlns:r="http://schemas.openxmlformats.org/officeDocument/2006/relationships">
+<p:sld xmlns:a="http://schemas.openxmlformats.org/drawingml/2006/main" xmlns:r="http://schemas.openxmlformats.org/officeDocument/2006/relationships" xmlns:p="http://schemas.openxmlformats.org/presentationml/2006/main">
   <p:cSld>
     <p:spTree>
       <p:nvGrpSpPr>
@@ -5845,7 +5918,14 @@
         <p:cNvGrpSpPr/>
         <p:nvPr/>
       </p:nvGrpSpPr>
-      <p:grpSpPr/>
+      <p:grpSpPr>
+        <a:xfrm>
+          <a:off x="0" y="0"/>
+          <a:ext cx="0" cy="0"/>
+          <a:chOff x="0" y="0"/>
+          <a:chExt cx="0" cy="0"/>
+        </a:xfrm>
+      </p:grpSpPr>
       <p:sp>
         <p:nvSpPr>
           <p:cNvPr id="2" name="TextBox 1"/>
@@ -5863,7 +5943,7 @@
           <a:noFill/>
         </p:spPr>
         <p:txBody>
-          <a:bodyPr wrap="square" anchor="t" lIns="0" rIns="0" tIns="0" bIns="0">
+          <a:bodyPr wrap="square" lIns="0" tIns="0" rIns="0" bIns="0" anchor="t">
             <a:spAutoFit/>
           </a:bodyPr>
           <a:lstStyle/>
@@ -5898,7 +5978,7 @@
           <a:noFill/>
         </p:spPr>
         <p:txBody>
-          <a:bodyPr wrap="square" anchor="t" lIns="0" rIns="0" tIns="0" bIns="0">
+          <a:bodyPr wrap="square" lIns="0" tIns="0" rIns="0" bIns="0" anchor="t">
             <a:spAutoFit/>
           </a:bodyPr>
           <a:lstStyle/>
@@ -5957,6 +6037,7 @@
           <a:lstStyle/>
           <a:p>
             <a:pPr algn="ctr"/>
+            <a:endParaRPr/>
           </a:p>
         </p:txBody>
       </p:sp>
@@ -6001,6 +6082,7 @@
           <a:lstStyle/>
           <a:p>
             <a:pPr algn="ctr"/>
+            <a:endParaRPr/>
           </a:p>
         </p:txBody>
       </p:sp>
@@ -6021,7 +6103,7 @@
           <a:noFill/>
         </p:spPr>
         <p:txBody>
-          <a:bodyPr wrap="square" anchor="t" lIns="0" rIns="0" tIns="0" bIns="0">
+          <a:bodyPr wrap="square" lIns="0" tIns="0" rIns="0" bIns="0" anchor="t">
             <a:spAutoFit/>
           </a:bodyPr>
           <a:lstStyle/>
@@ -6056,7 +6138,7 @@
           <a:noFill/>
         </p:spPr>
         <p:txBody>
-          <a:bodyPr wrap="square" anchor="t" lIns="0" rIns="0" tIns="0" bIns="0">
+          <a:bodyPr wrap="square" lIns="0" tIns="0" rIns="0" bIns="0" anchor="t">
             <a:spAutoFit/>
           </a:bodyPr>
           <a:lstStyle/>
@@ -6123,7 +6205,7 @@
           <a:noFill/>
         </p:spPr>
         <p:txBody>
-          <a:bodyPr wrap="square" anchor="t" lIns="0" rIns="0" tIns="0" bIns="0">
+          <a:bodyPr wrap="square" lIns="0" tIns="0" rIns="0" bIns="0" anchor="t">
             <a:spAutoFit/>
           </a:bodyPr>
           <a:lstStyle/>
@@ -6190,7 +6272,7 @@
           <a:noFill/>
         </p:spPr>
         <p:txBody>
-          <a:bodyPr wrap="square" anchor="t" lIns="0" rIns="0" tIns="0" bIns="0">
+          <a:bodyPr wrap="square" lIns="0" tIns="0" rIns="0" bIns="0" anchor="t">
             <a:spAutoFit/>
           </a:bodyPr>
           <a:lstStyle/>
@@ -6257,7 +6339,7 @@
           <a:noFill/>
         </p:spPr>
         <p:txBody>
-          <a:bodyPr wrap="square" anchor="t" lIns="0" rIns="0" tIns="0" bIns="0">
+          <a:bodyPr wrap="square" lIns="0" tIns="0" rIns="0" bIns="0" anchor="t">
             <a:spAutoFit/>
           </a:bodyPr>
           <a:lstStyle/>
@@ -6348,6 +6430,7 @@
           <a:lstStyle/>
           <a:p>
             <a:pPr algn="ctr"/>
+            <a:endParaRPr/>
           </a:p>
         </p:txBody>
       </p:sp>
@@ -6392,6 +6475,7 @@
           <a:lstStyle/>
           <a:p>
             <a:pPr algn="ctr"/>
+            <a:endParaRPr/>
           </a:p>
         </p:txBody>
       </p:sp>
@@ -6412,7 +6496,7 @@
           <a:noFill/>
         </p:spPr>
         <p:txBody>
-          <a:bodyPr wrap="square" anchor="t" lIns="0" rIns="0" tIns="0" bIns="0">
+          <a:bodyPr wrap="square" lIns="0" tIns="0" rIns="0" bIns="0" anchor="t">
             <a:spAutoFit/>
           </a:bodyPr>
           <a:lstStyle/>
@@ -6447,7 +6531,7 @@
           <a:noFill/>
         </p:spPr>
         <p:txBody>
-          <a:bodyPr wrap="square" anchor="t" lIns="0" rIns="0" tIns="0" bIns="0">
+          <a:bodyPr wrap="square" lIns="0" tIns="0" rIns="0" bIns="0" anchor="t">
             <a:spAutoFit/>
           </a:bodyPr>
           <a:lstStyle/>
@@ -6514,7 +6598,7 @@
           <a:noFill/>
         </p:spPr>
         <p:txBody>
-          <a:bodyPr wrap="square" anchor="t" lIns="0" rIns="0" tIns="0" bIns="0">
+          <a:bodyPr wrap="square" lIns="0" tIns="0" rIns="0" bIns="0" anchor="t">
             <a:spAutoFit/>
           </a:bodyPr>
           <a:lstStyle/>
@@ -6581,7 +6665,7 @@
           <a:noFill/>
         </p:spPr>
         <p:txBody>
-          <a:bodyPr wrap="square" anchor="t" lIns="0" rIns="0" tIns="0" bIns="0">
+          <a:bodyPr wrap="square" lIns="0" tIns="0" rIns="0" bIns="0" anchor="t">
             <a:spAutoFit/>
           </a:bodyPr>
           <a:lstStyle/>
@@ -6648,7 +6732,7 @@
           <a:noFill/>
         </p:spPr>
         <p:txBody>
-          <a:bodyPr wrap="square" anchor="t" lIns="0" rIns="0" tIns="0" bIns="0">
+          <a:bodyPr wrap="square" lIns="0" tIns="0" rIns="0" bIns="0" anchor="t">
             <a:spAutoFit/>
           </a:bodyPr>
           <a:lstStyle/>
@@ -6715,7 +6799,7 @@
           <a:noFill/>
         </p:spPr>
         <p:txBody>
-          <a:bodyPr wrap="square" anchor="t" lIns="0" rIns="0" tIns="0" bIns="0">
+          <a:bodyPr wrap="square" lIns="0" tIns="0" rIns="0" bIns="0" anchor="t">
             <a:spAutoFit/>
           </a:bodyPr>
           <a:lstStyle/>
@@ -6806,6 +6890,7 @@
           <a:lstStyle/>
           <a:p>
             <a:pPr algn="ctr"/>
+            <a:endParaRPr/>
           </a:p>
         </p:txBody>
       </p:sp>
@@ -6826,7 +6911,7 @@
           <a:noFill/>
         </p:spPr>
         <p:txBody>
-          <a:bodyPr wrap="square" anchor="t" lIns="0" rIns="0" tIns="0" bIns="0">
+          <a:bodyPr wrap="square" lIns="0" tIns="0" rIns="0" bIns="0" anchor="t">
             <a:spAutoFit/>
           </a:bodyPr>
           <a:lstStyle/>
@@ -6853,7 +6938,7 @@
 </file>
 
 <file path=ppt/slides/slide5.xml><?xml version="1.0" encoding="utf-8"?>
-<p:sld xmlns:a="http://schemas.openxmlformats.org/drawingml/2006/main" xmlns:p="http://schemas.openxmlformats.org/presentationml/2006/main" xmlns:r="http://schemas.openxmlformats.org/officeDocument/2006/relationships">
+<p:sld xmlns:a="http://schemas.openxmlformats.org/drawingml/2006/main" xmlns:r="http://schemas.openxmlformats.org/officeDocument/2006/relationships" xmlns:p="http://schemas.openxmlformats.org/presentationml/2006/main">
   <p:cSld>
     <p:spTree>
       <p:nvGrpSpPr>
@@ -6861,7 +6946,14 @@
         <p:cNvGrpSpPr/>
         <p:nvPr/>
       </p:nvGrpSpPr>
-      <p:grpSpPr/>
+      <p:grpSpPr>
+        <a:xfrm>
+          <a:off x="0" y="0"/>
+          <a:ext cx="0" cy="0"/>
+          <a:chOff x="0" y="0"/>
+          <a:chExt cx="0" cy="0"/>
+        </a:xfrm>
+      </p:grpSpPr>
       <p:sp>
         <p:nvSpPr>
           <p:cNvPr id="2" name="TextBox 1"/>
@@ -6879,7 +6971,7 @@
           <a:noFill/>
         </p:spPr>
         <p:txBody>
-          <a:bodyPr wrap="square" anchor="t" lIns="0" rIns="0" tIns="0" bIns="0">
+          <a:bodyPr wrap="square" lIns="0" tIns="0" rIns="0" bIns="0" anchor="t">
             <a:spAutoFit/>
           </a:bodyPr>
           <a:lstStyle/>
@@ -6914,7 +7006,7 @@
           <a:noFill/>
         </p:spPr>
         <p:txBody>
-          <a:bodyPr wrap="square" anchor="t" lIns="0" rIns="0" tIns="0" bIns="0">
+          <a:bodyPr wrap="square" lIns="0" tIns="0" rIns="0" bIns="0" anchor="t">
             <a:spAutoFit/>
           </a:bodyPr>
           <a:lstStyle/>
@@ -6973,6 +7065,7 @@
           <a:lstStyle/>
           <a:p>
             <a:pPr algn="ctr"/>
+            <a:endParaRPr/>
           </a:p>
         </p:txBody>
       </p:sp>
@@ -6993,7 +7086,7 @@
           <a:noFill/>
         </p:spPr>
         <p:txBody>
-          <a:bodyPr wrap="square" anchor="ctr" lIns="0" rIns="0" tIns="0" bIns="0">
+          <a:bodyPr wrap="square" lIns="0" tIns="0" rIns="0" bIns="0" anchor="ctr">
             <a:spAutoFit/>
           </a:bodyPr>
           <a:lstStyle/>
@@ -7053,7 +7146,7 @@
           <a:noFill/>
         </p:spPr>
         <p:txBody>
-          <a:bodyPr wrap="square" anchor="ctr" lIns="0" rIns="0" tIns="0" bIns="0">
+          <a:bodyPr wrap="square" lIns="0" tIns="0" rIns="0" bIns="0" anchor="ctr">
             <a:spAutoFit/>
           </a:bodyPr>
           <a:lstStyle/>
@@ -7088,7 +7181,7 @@
           <a:noFill/>
         </p:spPr>
         <p:txBody>
-          <a:bodyPr wrap="square" anchor="ctr" lIns="0" rIns="0" tIns="0" bIns="0">
+          <a:bodyPr wrap="square" lIns="0" tIns="0" rIns="0" bIns="0" anchor="ctr">
             <a:spAutoFit/>
           </a:bodyPr>
           <a:lstStyle/>
@@ -7148,7 +7241,7 @@
           <a:noFill/>
         </p:spPr>
         <p:txBody>
-          <a:bodyPr wrap="square" anchor="t" lIns="0" rIns="0" tIns="0" bIns="0">
+          <a:bodyPr wrap="square" lIns="0" tIns="0" rIns="0" bIns="0" anchor="t">
             <a:spAutoFit/>
           </a:bodyPr>
           <a:lstStyle/>
@@ -7207,6 +7300,7 @@
           <a:lstStyle/>
           <a:p>
             <a:pPr algn="ctr"/>
+            <a:endParaRPr/>
           </a:p>
         </p:txBody>
       </p:sp>
@@ -7251,6 +7345,7 @@
           <a:lstStyle/>
           <a:p>
             <a:pPr algn="ctr"/>
+            <a:endParaRPr/>
           </a:p>
         </p:txBody>
       </p:sp>
@@ -7271,7 +7366,7 @@
           <a:noFill/>
         </p:spPr>
         <p:txBody>
-          <a:bodyPr wrap="square" anchor="ctr" lIns="0" rIns="0" tIns="0" bIns="0">
+          <a:bodyPr wrap="square" lIns="0" tIns="0" rIns="0" bIns="0" anchor="ctr">
             <a:spAutoFit/>
           </a:bodyPr>
           <a:lstStyle/>
@@ -7306,7 +7401,7 @@
           <a:noFill/>
         </p:spPr>
         <p:txBody>
-          <a:bodyPr wrap="square" anchor="t" lIns="0" rIns="0" tIns="0" bIns="0">
+          <a:bodyPr wrap="square" lIns="0" tIns="0" rIns="0" bIns="0" anchor="t">
             <a:spAutoFit/>
           </a:bodyPr>
           <a:lstStyle/>
@@ -7388,6 +7483,7 @@
           <a:lstStyle/>
           <a:p>
             <a:pPr algn="ctr"/>
+            <a:endParaRPr/>
           </a:p>
         </p:txBody>
       </p:sp>
@@ -7432,6 +7528,7 @@
           <a:lstStyle/>
           <a:p>
             <a:pPr algn="ctr"/>
+            <a:endParaRPr/>
           </a:p>
         </p:txBody>
       </p:sp>
@@ -7452,7 +7549,7 @@
           <a:noFill/>
         </p:spPr>
         <p:txBody>
-          <a:bodyPr wrap="square" anchor="ctr" lIns="0" rIns="0" tIns="0" bIns="0">
+          <a:bodyPr wrap="square" lIns="0" tIns="0" rIns="0" bIns="0" anchor="ctr">
             <a:spAutoFit/>
           </a:bodyPr>
           <a:lstStyle/>
@@ -7487,7 +7584,7 @@
           <a:noFill/>
         </p:spPr>
         <p:txBody>
-          <a:bodyPr wrap="square" anchor="t" lIns="0" rIns="0" tIns="0" bIns="0">
+          <a:bodyPr wrap="square" lIns="0" tIns="0" rIns="0" bIns="0" anchor="t">
             <a:spAutoFit/>
           </a:bodyPr>
           <a:lstStyle/>
@@ -7569,6 +7666,7 @@
           <a:lstStyle/>
           <a:p>
             <a:pPr algn="ctr"/>
+            <a:endParaRPr/>
           </a:p>
         </p:txBody>
       </p:sp>
@@ -7613,6 +7711,7 @@
           <a:lstStyle/>
           <a:p>
             <a:pPr algn="ctr"/>
+            <a:endParaRPr/>
           </a:p>
         </p:txBody>
       </p:sp>
@@ -7633,7 +7732,7 @@
           <a:noFill/>
         </p:spPr>
         <p:txBody>
-          <a:bodyPr wrap="square" anchor="ctr" lIns="0" rIns="0" tIns="0" bIns="0">
+          <a:bodyPr wrap="square" lIns="0" tIns="0" rIns="0" bIns="0" anchor="ctr">
             <a:spAutoFit/>
           </a:bodyPr>
           <a:lstStyle/>
@@ -7668,7 +7767,7 @@
           <a:noFill/>
         </p:spPr>
         <p:txBody>
-          <a:bodyPr wrap="square" anchor="t" lIns="0" rIns="0" tIns="0" bIns="0">
+          <a:bodyPr wrap="square" lIns="0" tIns="0" rIns="0" bIns="0" anchor="t">
             <a:spAutoFit/>
           </a:bodyPr>
           <a:lstStyle/>
@@ -7750,6 +7849,7 @@
           <a:lstStyle/>
           <a:p>
             <a:pPr algn="ctr"/>
+            <a:endParaRPr/>
           </a:p>
         </p:txBody>
       </p:sp>
@@ -7770,7 +7870,7 @@
           <a:noFill/>
         </p:spPr>
         <p:txBody>
-          <a:bodyPr wrap="square" anchor="t" lIns="0" rIns="0" tIns="0" bIns="0">
+          <a:bodyPr wrap="square" lIns="0" tIns="0" rIns="0" bIns="0" anchor="t">
             <a:spAutoFit/>
           </a:bodyPr>
           <a:lstStyle/>
@@ -7797,7 +7897,7 @@
 </file>
 
 <file path=ppt/slides/slide6.xml><?xml version="1.0" encoding="utf-8"?>
-<p:sld xmlns:a="http://schemas.openxmlformats.org/drawingml/2006/main" xmlns:p="http://schemas.openxmlformats.org/presentationml/2006/main" xmlns:r="http://schemas.openxmlformats.org/officeDocument/2006/relationships">
+<p:sld xmlns:a="http://schemas.openxmlformats.org/drawingml/2006/main" xmlns:r="http://schemas.openxmlformats.org/officeDocument/2006/relationships" xmlns:p="http://schemas.openxmlformats.org/presentationml/2006/main">
   <p:cSld>
     <p:spTree>
       <p:nvGrpSpPr>
@@ -7805,7 +7905,14 @@
         <p:cNvGrpSpPr/>
         <p:nvPr/>
       </p:nvGrpSpPr>
-      <p:grpSpPr/>
+      <p:grpSpPr>
+        <a:xfrm>
+          <a:off x="0" y="0"/>
+          <a:ext cx="0" cy="0"/>
+          <a:chOff x="0" y="0"/>
+          <a:chExt cx="0" cy="0"/>
+        </a:xfrm>
+      </p:grpSpPr>
       <p:pic>
         <p:nvPicPr>
           <p:cNvPr id="2" name="Picture 1" descr="fase2a_microservicios_tradicionales.png"/>
@@ -7871,6 +7978,7 @@
           <a:lstStyle/>
           <a:p>
             <a:pPr algn="ctr"/>
+            <a:endParaRPr/>
           </a:p>
         </p:txBody>
       </p:sp>
@@ -7891,7 +7999,7 @@
           <a:noFill/>
         </p:spPr>
         <p:txBody>
-          <a:bodyPr wrap="square" anchor="t" lIns="0" rIns="0" tIns="0" bIns="0">
+          <a:bodyPr wrap="square" lIns="0" tIns="0" rIns="0" bIns="0" anchor="t">
             <a:spAutoFit/>
           </a:bodyPr>
           <a:lstStyle/>
@@ -7918,7 +8026,7 @@
 </file>
 
 <file path=ppt/slides/slide7.xml><?xml version="1.0" encoding="utf-8"?>
-<p:sld xmlns:a="http://schemas.openxmlformats.org/drawingml/2006/main" xmlns:p="http://schemas.openxmlformats.org/presentationml/2006/main" xmlns:r="http://schemas.openxmlformats.org/officeDocument/2006/relationships">
+<p:sld xmlns:a="http://schemas.openxmlformats.org/drawingml/2006/main" xmlns:r="http://schemas.openxmlformats.org/officeDocument/2006/relationships" xmlns:p="http://schemas.openxmlformats.org/presentationml/2006/main">
   <p:cSld>
     <p:spTree>
       <p:nvGrpSpPr>
@@ -7926,7 +8034,14 @@
         <p:cNvGrpSpPr/>
         <p:nvPr/>
       </p:nvGrpSpPr>
-      <p:grpSpPr/>
+      <p:grpSpPr>
+        <a:xfrm>
+          <a:off x="0" y="0"/>
+          <a:ext cx="0" cy="0"/>
+          <a:chOff x="0" y="0"/>
+          <a:chExt cx="0" cy="0"/>
+        </a:xfrm>
+      </p:grpSpPr>
       <p:pic>
         <p:nvPicPr>
           <p:cNvPr id="2" name="Picture 1" descr="fase2b_microservicios_modernos.png"/>
@@ -7992,6 +8107,7 @@
           <a:lstStyle/>
           <a:p>
             <a:pPr algn="ctr"/>
+            <a:endParaRPr/>
           </a:p>
         </p:txBody>
       </p:sp>
@@ -8012,7 +8128,7 @@
           <a:noFill/>
         </p:spPr>
         <p:txBody>
-          <a:bodyPr wrap="square" anchor="t" lIns="0" rIns="0" tIns="0" bIns="0">
+          <a:bodyPr wrap="square" lIns="0" tIns="0" rIns="0" bIns="0" anchor="t">
             <a:spAutoFit/>
           </a:bodyPr>
           <a:lstStyle/>
@@ -8039,7 +8155,7 @@
 </file>
 
 <file path=ppt/slides/slide8.xml><?xml version="1.0" encoding="utf-8"?>
-<p:sld xmlns:a="http://schemas.openxmlformats.org/drawingml/2006/main" xmlns:p="http://schemas.openxmlformats.org/presentationml/2006/main" xmlns:r="http://schemas.openxmlformats.org/officeDocument/2006/relationships">
+<p:sld xmlns:a="http://schemas.openxmlformats.org/drawingml/2006/main" xmlns:r="http://schemas.openxmlformats.org/officeDocument/2006/relationships" xmlns:p="http://schemas.openxmlformats.org/presentationml/2006/main">
   <p:cSld>
     <p:spTree>
       <p:nvGrpSpPr>
@@ -8047,7 +8163,14 @@
         <p:cNvGrpSpPr/>
         <p:nvPr/>
       </p:nvGrpSpPr>
-      <p:grpSpPr/>
+      <p:grpSpPr>
+        <a:xfrm>
+          <a:off x="0" y="0"/>
+          <a:ext cx="0" cy="0"/>
+          <a:chOff x="0" y="0"/>
+          <a:chExt cx="0" cy="0"/>
+        </a:xfrm>
+      </p:grpSpPr>
       <p:pic>
         <p:nvPicPr>
           <p:cNvPr id="2" name="Picture 1" descr="fase3_arquitectura_escalada.png"/>
@@ -8113,6 +8236,7 @@
           <a:lstStyle/>
           <a:p>
             <a:pPr algn="ctr"/>
+            <a:endParaRPr/>
           </a:p>
         </p:txBody>
       </p:sp>
@@ -8133,7 +8257,7 @@
           <a:noFill/>
         </p:spPr>
         <p:txBody>
-          <a:bodyPr wrap="square" anchor="t" lIns="0" rIns="0" tIns="0" bIns="0">
+          <a:bodyPr wrap="square" lIns="0" tIns="0" rIns="0" bIns="0" anchor="t">
             <a:spAutoFit/>
           </a:bodyPr>
           <a:lstStyle/>
@@ -8160,7 +8284,7 @@
 </file>
 
 <file path=ppt/slides/slide9.xml><?xml version="1.0" encoding="utf-8"?>
-<p:sld xmlns:a="http://schemas.openxmlformats.org/drawingml/2006/main" xmlns:p="http://schemas.openxmlformats.org/presentationml/2006/main" xmlns:r="http://schemas.openxmlformats.org/officeDocument/2006/relationships">
+<p:sld xmlns:a="http://schemas.openxmlformats.org/drawingml/2006/main" xmlns:r="http://schemas.openxmlformats.org/officeDocument/2006/relationships" xmlns:p="http://schemas.openxmlformats.org/presentationml/2006/main">
   <p:cSld>
     <p:spTree>
       <p:nvGrpSpPr>
@@ -8168,7 +8292,14 @@
         <p:cNvGrpSpPr/>
         <p:nvPr/>
       </p:nvGrpSpPr>
-      <p:grpSpPr/>
+      <p:grpSpPr>
+        <a:xfrm>
+          <a:off x="0" y="0"/>
+          <a:ext cx="0" cy="0"/>
+          <a:chOff x="0" y="0"/>
+          <a:chExt cx="0" cy="0"/>
+        </a:xfrm>
+      </p:grpSpPr>
       <p:sp>
         <p:nvSpPr>
           <p:cNvPr id="2" name="TextBox 1"/>
@@ -8186,7 +8317,7 @@
           <a:noFill/>
         </p:spPr>
         <p:txBody>
-          <a:bodyPr wrap="square" anchor="t" lIns="0" rIns="0" tIns="0" bIns="0">
+          <a:bodyPr wrap="square" lIns="0" tIns="0" rIns="0" bIns="0" anchor="t">
             <a:spAutoFit/>
           </a:bodyPr>
           <a:lstStyle/>
@@ -8221,7 +8352,7 @@
           <a:noFill/>
         </p:spPr>
         <p:txBody>
-          <a:bodyPr wrap="square" anchor="t" lIns="0" rIns="0" tIns="0" bIns="0">
+          <a:bodyPr wrap="square" lIns="0" tIns="0" rIns="0" bIns="0" anchor="t">
             <a:spAutoFit/>
           </a:bodyPr>
           <a:lstStyle/>
@@ -8280,6 +8411,7 @@
           <a:lstStyle/>
           <a:p>
             <a:pPr algn="ctr"/>
+            <a:endParaRPr/>
           </a:p>
         </p:txBody>
       </p:sp>
@@ -8324,6 +8456,7 @@
           <a:lstStyle/>
           <a:p>
             <a:pPr algn="ctr"/>
+            <a:endParaRPr/>
           </a:p>
         </p:txBody>
       </p:sp>
@@ -8344,7 +8477,7 @@
           <a:noFill/>
         </p:spPr>
         <p:txBody>
-          <a:bodyPr wrap="square" anchor="t" lIns="0" rIns="0" tIns="0" bIns="0">
+          <a:bodyPr wrap="square" lIns="0" tIns="0" rIns="0" bIns="0" anchor="t">
             <a:spAutoFit/>
           </a:bodyPr>
           <a:lstStyle/>
@@ -8466,6 +8599,7 @@
           <a:lstStyle/>
           <a:p>
             <a:pPr algn="ctr"/>
+            <a:endParaRPr/>
           </a:p>
         </p:txBody>
       </p:sp>
@@ -8510,6 +8644,7 @@
           <a:lstStyle/>
           <a:p>
             <a:pPr algn="ctr"/>
+            <a:endParaRPr/>
           </a:p>
         </p:txBody>
       </p:sp>
@@ -8530,7 +8665,7 @@
           <a:noFill/>
         </p:spPr>
         <p:txBody>
-          <a:bodyPr wrap="square" anchor="t" lIns="0" rIns="0" tIns="0" bIns="0">
+          <a:bodyPr wrap="square" lIns="0" tIns="0" rIns="0" bIns="0" anchor="t">
             <a:spAutoFit/>
           </a:bodyPr>
           <a:lstStyle/>
@@ -8652,6 +8787,7 @@
           <a:lstStyle/>
           <a:p>
             <a:pPr algn="ctr"/>
+            <a:endParaRPr/>
           </a:p>
         </p:txBody>
       </p:sp>
@@ -8696,6 +8832,7 @@
           <a:lstStyle/>
           <a:p>
             <a:pPr algn="ctr"/>
+            <a:endParaRPr/>
           </a:p>
         </p:txBody>
       </p:sp>
@@ -8716,7 +8853,7 @@
           <a:noFill/>
         </p:spPr>
         <p:txBody>
-          <a:bodyPr wrap="square" anchor="t" lIns="0" rIns="0" tIns="0" bIns="0">
+          <a:bodyPr wrap="square" lIns="0" tIns="0" rIns="0" bIns="0" anchor="t">
             <a:spAutoFit/>
           </a:bodyPr>
           <a:lstStyle/>
@@ -8838,6 +8975,7 @@
           <a:lstStyle/>
           <a:p>
             <a:pPr algn="ctr"/>
+            <a:endParaRPr/>
           </a:p>
         </p:txBody>
       </p:sp>
@@ -8882,6 +9020,7 @@
           <a:lstStyle/>
           <a:p>
             <a:pPr algn="ctr"/>
+            <a:endParaRPr/>
           </a:p>
         </p:txBody>
       </p:sp>
@@ -8902,7 +9041,7 @@
           <a:noFill/>
         </p:spPr>
         <p:txBody>
-          <a:bodyPr wrap="square" anchor="t" lIns="0" rIns="0" tIns="0" bIns="0">
+          <a:bodyPr wrap="square" lIns="0" tIns="0" rIns="0" bIns="0" anchor="t">
             <a:spAutoFit/>
           </a:bodyPr>
           <a:lstStyle/>
@@ -9024,6 +9163,7 @@
           <a:lstStyle/>
           <a:p>
             <a:pPr algn="ctr"/>
+            <a:endParaRPr/>
           </a:p>
         </p:txBody>
       </p:sp>
@@ -9044,7 +9184,7 @@
           <a:noFill/>
         </p:spPr>
         <p:txBody>
-          <a:bodyPr wrap="square" anchor="ctr" lIns="0" rIns="0" tIns="0" bIns="0">
+          <a:bodyPr wrap="square" lIns="0" tIns="0" rIns="0" bIns="0" anchor="ctr">
             <a:spAutoFit/>
           </a:bodyPr>
           <a:lstStyle/>
@@ -9112,6 +9252,7 @@
           <a:lstStyle/>
           <a:p>
             <a:pPr algn="ctr"/>
+            <a:endParaRPr/>
           </a:p>
         </p:txBody>
       </p:sp>
@@ -9132,7 +9273,7 @@
           <a:noFill/>
         </p:spPr>
         <p:txBody>
-          <a:bodyPr wrap="square" anchor="t" lIns="0" rIns="0" tIns="0" bIns="0">
+          <a:bodyPr wrap="square" lIns="0" tIns="0" rIns="0" bIns="0" anchor="t">
             <a:spAutoFit/>
           </a:bodyPr>
           <a:lstStyle/>

</xml_diff>